<commit_message>
Improve incident response gold slide visuals
</commit_message>
<xml_diff>
--- a/poc/tasks/incident_response_annotated_deck/artifacts/gold/final.pptx
+++ b/poc/tasks/incident_response_annotated_deck/artifacts/gold/final.pptx
@@ -3334,7 +3334,52 @@
       <p:grpSpPr/>
       <p:sp>
         <p:nvSpPr>
-          <p:cNvPr id="2" name="slide2_title"/>
+          <p:cNvPr id="2" name="Rectangle 1"/>
+          <p:cNvSpPr/>
+          <p:nvPr/>
+        </p:nvSpPr>
+        <p:spPr>
+          <a:xfrm>
+            <a:off x="0" y="0"/>
+            <a:ext cx="12188952" cy="182880"/>
+          </a:xfrm>
+          <a:prstGeom prst="rect">
+            <a:avLst/>
+          </a:prstGeom>
+          <a:solidFill>
+            <a:srgbClr val="1F4E79"/>
+          </a:solidFill>
+          <a:ln w="15875">
+            <a:solidFill>
+              <a:srgbClr val="1F4E79"/>
+            </a:solidFill>
+          </a:ln>
+        </p:spPr>
+        <p:style>
+          <a:lnRef idx="1">
+            <a:schemeClr val="accent1"/>
+          </a:lnRef>
+          <a:fillRef idx="3">
+            <a:schemeClr val="accent1"/>
+          </a:fillRef>
+          <a:effectRef idx="2">
+            <a:schemeClr val="accent1"/>
+          </a:effectRef>
+          <a:fontRef idx="minor">
+            <a:schemeClr val="lt1"/>
+          </a:fontRef>
+        </p:style>
+        <p:txBody>
+          <a:bodyPr rtlCol="0" anchor="ctr"/>
+          <a:lstStyle/>
+          <a:p>
+            <a:pPr algn="ctr"/>
+          </a:p>
+        </p:txBody>
+      </p:sp>
+      <p:sp>
+        <p:nvSpPr>
+          <p:cNvPr id="3" name="slide2_title"/>
           <p:cNvSpPr txBox="1"/>
           <p:nvPr/>
         </p:nvSpPr>
@@ -3367,7 +3412,60 @@
       </p:sp>
       <p:sp>
         <p:nvSpPr>
-          <p:cNvPr id="3" name="TextBox 2"/>
+          <p:cNvPr id="4" name="Rounded Rectangle 3"/>
+          <p:cNvSpPr/>
+          <p:nvPr/>
+        </p:nvSpPr>
+        <p:spPr>
+          <a:xfrm>
+            <a:off x="9281160" y="384048"/>
+            <a:ext cx="2084831" cy="310896"/>
+          </a:xfrm>
+          <a:prstGeom prst="roundRect">
+            <a:avLst/>
+          </a:prstGeom>
+          <a:solidFill>
+            <a:srgbClr val="FFFFFF"/>
+          </a:solidFill>
+          <a:ln w="15875">
+            <a:solidFill>
+              <a:srgbClr val="BECBDA"/>
+            </a:solidFill>
+          </a:ln>
+        </p:spPr>
+        <p:style>
+          <a:lnRef idx="1">
+            <a:schemeClr val="accent1"/>
+          </a:lnRef>
+          <a:fillRef idx="3">
+            <a:schemeClr val="accent1"/>
+          </a:fillRef>
+          <a:effectRef idx="2">
+            <a:schemeClr val="accent1"/>
+          </a:effectRef>
+          <a:fontRef idx="minor">
+            <a:schemeClr val="lt1"/>
+          </a:fontRef>
+        </p:style>
+        <p:txBody>
+          <a:bodyPr rtlCol="0" anchor="ctr" lIns="36576" rIns="36576" tIns="36576" bIns="36576"/>
+          <a:lstStyle/>
+          <a:p>
+            <a:pPr algn="ctr"/>
+            <a:r>
+              <a:rPr sz="1150" b="1">
+                <a:solidFill>
+                  <a:srgbClr val="1F4E79"/>
+                </a:solidFill>
+              </a:rPr>
+              <a:t>APRIL SERVICE REVIEW</a:t>
+            </a:r>
+          </a:p>
+        </p:txBody>
+      </p:sp>
+      <p:sp>
+        <p:nvSpPr>
+          <p:cNvPr id="5" name="TextBox 4"/>
           <p:cNvSpPr txBox="1"/>
           <p:nvPr/>
         </p:nvSpPr>
@@ -3400,14 +3498,345 @@
       </p:sp>
       <p:sp>
         <p:nvSpPr>
-          <p:cNvPr id="4" name="MTTA 8 min"/>
+          <p:cNvPr id="6" name="MTTA 8 min&#10;Target &lt;=10 min&#10;+2 min buffer"/>
           <p:cNvSpPr/>
           <p:nvPr/>
         </p:nvSpPr>
         <p:spPr>
           <a:xfrm>
-            <a:off x="621792" y="1207008"/>
-            <a:ext cx="3063240" cy="694944"/>
+            <a:off x="621792" y="1188720"/>
+            <a:ext cx="2816352" cy="859536"/>
+          </a:xfrm>
+          <a:prstGeom prst="roundRect">
+            <a:avLst/>
+          </a:prstGeom>
+          <a:solidFill>
+            <a:srgbClr val="E7F1FB"/>
+          </a:solidFill>
+          <a:ln w="19050">
+            <a:solidFill>
+              <a:srgbClr val="AEC1D3"/>
+            </a:solidFill>
+          </a:ln>
+        </p:spPr>
+        <p:style>
+          <a:lnRef idx="1">
+            <a:schemeClr val="accent1"/>
+          </a:lnRef>
+          <a:fillRef idx="3">
+            <a:schemeClr val="accent1"/>
+          </a:fillRef>
+          <a:effectRef idx="2">
+            <a:schemeClr val="accent1"/>
+          </a:effectRef>
+          <a:fontRef idx="minor">
+            <a:schemeClr val="lt1"/>
+          </a:fontRef>
+        </p:style>
+        <p:txBody>
+          <a:bodyPr rtlCol="0" anchor="ctr" lIns="73152" rIns="73152" tIns="73152" bIns="73152"/>
+          <a:lstStyle/>
+          <a:p>
+            <a:pPr algn="ctr"/>
+            <a:r>
+              <a:rPr sz="1500" b="1">
+                <a:solidFill>
+                  <a:srgbClr val="172033"/>
+                </a:solidFill>
+              </a:rPr>
+              <a:t>MTTA 8 min
+Target &lt;=10 min
++2 min buffer</a:t>
+            </a:r>
+          </a:p>
+        </p:txBody>
+      </p:sp>
+      <p:sp>
+        <p:nvSpPr>
+          <p:cNvPr id="7" name="Backlog 42&#10;15 need SEV-2 review&#10;Owner gap"/>
+          <p:cNvSpPr/>
+          <p:nvPr/>
+        </p:nvSpPr>
+        <p:spPr>
+          <a:xfrm>
+            <a:off x="4498848" y="1188720"/>
+            <a:ext cx="2816352" cy="859536"/>
+          </a:xfrm>
+          <a:prstGeom prst="roundRect">
+            <a:avLst/>
+          </a:prstGeom>
+          <a:solidFill>
+            <a:srgbClr val="EEF4FB"/>
+          </a:solidFill>
+          <a:ln w="19050">
+            <a:solidFill>
+              <a:srgbClr val="AEC1D3"/>
+            </a:solidFill>
+          </a:ln>
+        </p:spPr>
+        <p:style>
+          <a:lnRef idx="1">
+            <a:schemeClr val="accent1"/>
+          </a:lnRef>
+          <a:fillRef idx="3">
+            <a:schemeClr val="accent1"/>
+          </a:fillRef>
+          <a:effectRef idx="2">
+            <a:schemeClr val="accent1"/>
+          </a:effectRef>
+          <a:fontRef idx="minor">
+            <a:schemeClr val="lt1"/>
+          </a:fontRef>
+        </p:style>
+        <p:txBody>
+          <a:bodyPr rtlCol="0" anchor="ctr" lIns="73152" rIns="73152" tIns="73152" bIns="73152"/>
+          <a:lstStyle/>
+          <a:p>
+            <a:pPr algn="ctr"/>
+            <a:r>
+              <a:rPr sz="1500" b="1">
+                <a:solidFill>
+                  <a:srgbClr val="172033"/>
+                </a:solidFill>
+              </a:rPr>
+              <a:t>Backlog 42
+15 need SEV-2 review
+Owner gap</a:t>
+            </a:r>
+          </a:p>
+        </p:txBody>
+      </p:sp>
+      <p:sp>
+        <p:nvSpPr>
+          <p:cNvPr id="8" name="Coverage 92%&#10;Weekend rota live&#10;Watch Friday"/>
+          <p:cNvSpPr/>
+          <p:nvPr/>
+        </p:nvSpPr>
+        <p:spPr>
+          <a:xfrm>
+            <a:off x="8375904" y="1188720"/>
+            <a:ext cx="2816352" cy="859536"/>
+          </a:xfrm>
+          <a:prstGeom prst="roundRect">
+            <a:avLst/>
+          </a:prstGeom>
+          <a:solidFill>
+            <a:srgbClr val="E9F7F0"/>
+          </a:solidFill>
+          <a:ln w="19050">
+            <a:solidFill>
+              <a:srgbClr val="AEC1D3"/>
+            </a:solidFill>
+          </a:ln>
+        </p:spPr>
+        <p:style>
+          <a:lnRef idx="1">
+            <a:schemeClr val="accent1"/>
+          </a:lnRef>
+          <a:fillRef idx="3">
+            <a:schemeClr val="accent1"/>
+          </a:fillRef>
+          <a:effectRef idx="2">
+            <a:schemeClr val="accent1"/>
+          </a:effectRef>
+          <a:fontRef idx="minor">
+            <a:schemeClr val="lt1"/>
+          </a:fontRef>
+        </p:style>
+        <p:txBody>
+          <a:bodyPr rtlCol="0" anchor="ctr" lIns="73152" rIns="73152" tIns="73152" bIns="73152"/>
+          <a:lstStyle/>
+          <a:p>
+            <a:pPr algn="ctr"/>
+            <a:r>
+              <a:rPr sz="1500" b="1">
+                <a:solidFill>
+                  <a:srgbClr val="172033"/>
+                </a:solidFill>
+              </a:rPr>
+              <a:t>Coverage 92%
+Weekend rota live
+Watch Friday</a:t>
+            </a:r>
+          </a:p>
+        </p:txBody>
+      </p:sp>
+      <p:sp>
+        <p:nvSpPr>
+          <p:cNvPr id="9" name="incident_trend_panel"/>
+          <p:cNvSpPr/>
+          <p:nvPr/>
+        </p:nvSpPr>
+        <p:spPr>
+          <a:xfrm>
+            <a:off x="658368" y="2286000"/>
+            <a:ext cx="6903720" cy="2944368"/>
+          </a:xfrm>
+          <a:prstGeom prst="roundRect">
+            <a:avLst/>
+          </a:prstGeom>
+          <a:solidFill>
+            <a:srgbClr val="FFFFFF"/>
+          </a:solidFill>
+          <a:ln w="25400">
+            <a:solidFill>
+              <a:srgbClr val="748CA6"/>
+            </a:solidFill>
+          </a:ln>
+        </p:spPr>
+        <p:style>
+          <a:lnRef idx="1">
+            <a:schemeClr val="accent1"/>
+          </a:lnRef>
+          <a:fillRef idx="3">
+            <a:schemeClr val="accent1"/>
+          </a:fillRef>
+          <a:effectRef idx="2">
+            <a:schemeClr val="accent1"/>
+          </a:effectRef>
+          <a:fontRef idx="minor">
+            <a:schemeClr val="lt1"/>
+          </a:fontRef>
+        </p:style>
+        <p:txBody>
+          <a:bodyPr rtlCol="0" anchor="ctr"/>
+          <a:lstStyle/>
+          <a:p>
+            <a:pPr algn="ctr"/>
+          </a:p>
+        </p:txBody>
+      </p:sp>
+      <p:sp>
+        <p:nvSpPr>
+          <p:cNvPr id="10" name="TextBox 9"/>
+          <p:cNvSpPr txBox="1"/>
+          <p:nvPr/>
+        </p:nvSpPr>
+        <p:spPr>
+          <a:xfrm>
+            <a:off x="932688" y="2487168"/>
+            <a:ext cx="2194560" cy="256032"/>
+          </a:xfrm>
+          <a:prstGeom prst="rect">
+            <a:avLst/>
+          </a:prstGeom>
+          <a:noFill/>
+        </p:spPr>
+        <p:txBody>
+          <a:bodyPr wrap="none" lIns="73152" rIns="73152" tIns="73152" bIns="73152">
+            <a:spAutoFit/>
+          </a:bodyPr>
+          <a:lstStyle/>
+          <a:p>
+            <a:r>
+              <a:rPr sz="1200" b="1">
+                <a:solidFill>
+                  <a:srgbClr val="1F4E79"/>
+                </a:solidFill>
+              </a:rPr>
+              <a:t>INCIDENT TREND</a:t>
+            </a:r>
+          </a:p>
+        </p:txBody>
+      </p:sp>
+      <p:sp>
+        <p:nvSpPr>
+          <p:cNvPr id="11" name="TextBox 10"/>
+          <p:cNvSpPr txBox="1"/>
+          <p:nvPr/>
+        </p:nvSpPr>
+        <p:spPr>
+          <a:xfrm>
+            <a:off x="950976" y="2798064"/>
+            <a:ext cx="2103120" cy="201168"/>
+          </a:xfrm>
+          <a:prstGeom prst="rect">
+            <a:avLst/>
+          </a:prstGeom>
+          <a:noFill/>
+        </p:spPr>
+        <p:txBody>
+          <a:bodyPr wrap="none" lIns="27432" rIns="27432" tIns="27432" bIns="27432">
+            <a:spAutoFit/>
+          </a:bodyPr>
+          <a:lstStyle/>
+          <a:p>
+            <a:r>
+              <a:rPr sz="1050" b="0">
+                <a:solidFill>
+                  <a:srgbClr val="586778"/>
+                </a:solidFill>
+              </a:rPr>
+              <a:t>Severity mix, last 7 days</a:t>
+            </a:r>
+          </a:p>
+        </p:txBody>
+      </p:sp>
+      <p:sp>
+        <p:nvSpPr>
+          <p:cNvPr id="12" name="Rounded Rectangle 11"/>
+          <p:cNvSpPr/>
+          <p:nvPr/>
+        </p:nvSpPr>
+        <p:spPr>
+          <a:xfrm>
+            <a:off x="914400" y="3200400"/>
+            <a:ext cx="1572768" cy="804672"/>
+          </a:xfrm>
+          <a:prstGeom prst="roundRect">
+            <a:avLst/>
+          </a:prstGeom>
+          <a:solidFill>
+            <a:srgbClr val="F7FAFD"/>
+          </a:solidFill>
+          <a:ln w="15875">
+            <a:solidFill>
+              <a:srgbClr val="E1E7EE"/>
+            </a:solidFill>
+          </a:ln>
+        </p:spPr>
+        <p:style>
+          <a:lnRef idx="1">
+            <a:schemeClr val="accent1"/>
+          </a:lnRef>
+          <a:fillRef idx="3">
+            <a:schemeClr val="accent1"/>
+          </a:fillRef>
+          <a:effectRef idx="2">
+            <a:schemeClr val="accent1"/>
+          </a:effectRef>
+          <a:fontRef idx="minor">
+            <a:schemeClr val="lt1"/>
+          </a:fontRef>
+        </p:style>
+        <p:txBody>
+          <a:bodyPr rtlCol="0" anchor="ctr" lIns="45720" rIns="45720"/>
+          <a:lstStyle/>
+          <a:p>
+            <a:pPr algn="ctr"/>
+            <a:r>
+              <a:rPr sz="1150" b="0">
+                <a:solidFill>
+                  <a:srgbClr val="172033"/>
+                </a:solidFill>
+              </a:rPr>
+              <a:t>P1 incidents: 3
+P2 incidents: 11
+P3 incidents: 28</a:t>
+            </a:r>
+          </a:p>
+        </p:txBody>
+      </p:sp>
+      <p:sp>
+        <p:nvSpPr>
+          <p:cNvPr id="13" name="Rounded Rectangle 12"/>
+          <p:cNvSpPr/>
+          <p:nvPr/>
+        </p:nvSpPr>
+        <p:spPr>
+          <a:xfrm>
+            <a:off x="5074920" y="2688336"/>
+            <a:ext cx="1975104" cy="530352"/>
           </a:xfrm>
           <a:prstGeom prst="roundRect">
             <a:avLst/>
@@ -3436,41 +3865,75 @@
           </a:fontRef>
         </p:style>
         <p:txBody>
-          <a:bodyPr rtlCol="0" anchor="ctr" lIns="73152" rIns="73152" tIns="73152" bIns="73152"/>
+          <a:bodyPr rtlCol="0" anchor="ctr" lIns="45720" rIns="45720"/>
           <a:lstStyle/>
           <a:p>
             <a:pPr algn="ctr"/>
             <a:r>
-              <a:rPr sz="2000" b="1">
-                <a:solidFill>
-                  <a:srgbClr val="172033"/>
+              <a:rPr sz="1100" b="1">
+                <a:solidFill>
+                  <a:srgbClr val="194977"/>
                 </a:solidFill>
               </a:rPr>
-              <a:t>MTTA 8 min</a:t>
-            </a:r>
-          </a:p>
-        </p:txBody>
-      </p:sp>
-      <p:sp>
-        <p:nvSpPr>
-          <p:cNvPr id="5" name="Backlog 42"/>
+              <a:t>Trend down 18% WoW
+Driver: owner cleanup</a:t>
+            </a:r>
+          </a:p>
+        </p:txBody>
+      </p:sp>
+      <p:sp>
+        <p:nvSpPr>
+          <p:cNvPr id="14" name="TextBox 13"/>
+          <p:cNvSpPr txBox="1"/>
+          <p:nvPr/>
+        </p:nvSpPr>
+        <p:spPr>
+          <a:xfrm>
+            <a:off x="2542032" y="3200400"/>
+            <a:ext cx="502920" cy="201168"/>
+          </a:xfrm>
+          <a:prstGeom prst="rect">
+            <a:avLst/>
+          </a:prstGeom>
+          <a:noFill/>
+        </p:spPr>
+        <p:txBody>
+          <a:bodyPr wrap="none" lIns="27432" rIns="27432" tIns="27432" bIns="27432">
+            <a:spAutoFit/>
+          </a:bodyPr>
+          <a:lstStyle/>
+          <a:p>
+            <a:r>
+              <a:rPr sz="1050" b="1">
+                <a:solidFill>
+                  <a:srgbClr val="586778"/>
+                </a:solidFill>
+              </a:rPr>
+              <a:t>Count</a:t>
+            </a:r>
+          </a:p>
+        </p:txBody>
+      </p:sp>
+      <p:sp>
+        <p:nvSpPr>
+          <p:cNvPr id="15" name="Rectangle 14"/>
           <p:cNvSpPr/>
           <p:nvPr/>
         </p:nvSpPr>
         <p:spPr>
           <a:xfrm>
-            <a:off x="4498848" y="1207008"/>
-            <a:ext cx="3063240" cy="694944"/>
-          </a:xfrm>
-          <a:prstGeom prst="roundRect">
+            <a:off x="2980944" y="3456432"/>
+            <a:ext cx="9144" cy="1225296"/>
+          </a:xfrm>
+          <a:prstGeom prst="rect">
             <a:avLst/>
           </a:prstGeom>
           <a:solidFill>
-            <a:srgbClr val="E7F1FB"/>
+            <a:srgbClr val="D5DEE8"/>
           </a:solidFill>
           <a:ln w="15875">
             <a:solidFill>
-              <a:srgbClr val="AEC1D3"/>
+              <a:srgbClr val="D5DEE8"/>
             </a:solidFill>
           </a:ln>
         </p:spPr>
@@ -3489,41 +3952,66 @@
           </a:fontRef>
         </p:style>
         <p:txBody>
-          <a:bodyPr rtlCol="0" anchor="ctr" lIns="73152" rIns="73152" tIns="73152" bIns="73152"/>
+          <a:bodyPr rtlCol="0" anchor="ctr"/>
           <a:lstStyle/>
           <a:p>
             <a:pPr algn="ctr"/>
-            <a:r>
-              <a:rPr sz="2000" b="1">
-                <a:solidFill>
-                  <a:srgbClr val="172033"/>
+          </a:p>
+        </p:txBody>
+      </p:sp>
+      <p:sp>
+        <p:nvSpPr>
+          <p:cNvPr id="16" name="TextBox 15"/>
+          <p:cNvSpPr txBox="1"/>
+          <p:nvPr/>
+        </p:nvSpPr>
+        <p:spPr>
+          <a:xfrm>
+            <a:off x="2916936" y="4736592"/>
+            <a:ext cx="274320" cy="146304"/>
+          </a:xfrm>
+          <a:prstGeom prst="rect">
+            <a:avLst/>
+          </a:prstGeom>
+          <a:noFill/>
+        </p:spPr>
+        <p:txBody>
+          <a:bodyPr wrap="none" lIns="27432" rIns="27432" tIns="27432" bIns="27432">
+            <a:spAutoFit/>
+          </a:bodyPr>
+          <a:lstStyle/>
+          <a:p>
+            <a:r>
+              <a:rPr sz="1050" b="0">
+                <a:solidFill>
+                  <a:srgbClr val="586778"/>
                 </a:solidFill>
               </a:rPr>
-              <a:t>Backlog 42</a:t>
-            </a:r>
-          </a:p>
-        </p:txBody>
-      </p:sp>
-      <p:sp>
-        <p:nvSpPr>
-          <p:cNvPr id="6" name="Coverage 92%"/>
+              <a:t>0</a:t>
+            </a:r>
+          </a:p>
+        </p:txBody>
+      </p:sp>
+      <p:sp>
+        <p:nvSpPr>
+          <p:cNvPr id="17" name="Rectangle 16"/>
           <p:cNvSpPr/>
           <p:nvPr/>
         </p:nvSpPr>
         <p:spPr>
           <a:xfrm>
-            <a:off x="8375904" y="1207008"/>
-            <a:ext cx="3063240" cy="694944"/>
-          </a:xfrm>
-          <a:prstGeom prst="roundRect">
+            <a:off x="4041648" y="3456432"/>
+            <a:ext cx="9144" cy="1225296"/>
+          </a:xfrm>
+          <a:prstGeom prst="rect">
             <a:avLst/>
           </a:prstGeom>
           <a:solidFill>
-            <a:srgbClr val="E7F1FB"/>
+            <a:srgbClr val="D5DEE8"/>
           </a:solidFill>
           <a:ln w="15875">
             <a:solidFill>
-              <a:srgbClr val="AEC1D3"/>
+              <a:srgbClr val="D5DEE8"/>
             </a:solidFill>
           </a:ln>
         </p:spPr>
@@ -3542,41 +4030,66 @@
           </a:fontRef>
         </p:style>
         <p:txBody>
-          <a:bodyPr rtlCol="0" anchor="ctr" lIns="73152" rIns="73152" tIns="73152" bIns="73152"/>
+          <a:bodyPr rtlCol="0" anchor="ctr"/>
           <a:lstStyle/>
           <a:p>
             <a:pPr algn="ctr"/>
-            <a:r>
-              <a:rPr sz="2000" b="1">
-                <a:solidFill>
-                  <a:srgbClr val="172033"/>
+          </a:p>
+        </p:txBody>
+      </p:sp>
+      <p:sp>
+        <p:nvSpPr>
+          <p:cNvPr id="18" name="TextBox 17"/>
+          <p:cNvSpPr txBox="1"/>
+          <p:nvPr/>
+        </p:nvSpPr>
+        <p:spPr>
+          <a:xfrm>
+            <a:off x="3977639" y="4736592"/>
+            <a:ext cx="274320" cy="146304"/>
+          </a:xfrm>
+          <a:prstGeom prst="rect">
+            <a:avLst/>
+          </a:prstGeom>
+          <a:noFill/>
+        </p:spPr>
+        <p:txBody>
+          <a:bodyPr wrap="none" lIns="27432" rIns="27432" tIns="27432" bIns="27432">
+            <a:spAutoFit/>
+          </a:bodyPr>
+          <a:lstStyle/>
+          <a:p>
+            <a:r>
+              <a:rPr sz="1050" b="0">
+                <a:solidFill>
+                  <a:srgbClr val="586778"/>
                 </a:solidFill>
               </a:rPr>
-              <a:t>Coverage 92%</a:t>
-            </a:r>
-          </a:p>
-        </p:txBody>
-      </p:sp>
-      <p:sp>
-        <p:nvSpPr>
-          <p:cNvPr id="7" name="incident_trend_panel"/>
+              <a:t>10</a:t>
+            </a:r>
+          </a:p>
+        </p:txBody>
+      </p:sp>
+      <p:sp>
+        <p:nvSpPr>
+          <p:cNvPr id="19" name="Rectangle 18"/>
           <p:cNvSpPr/>
           <p:nvPr/>
         </p:nvSpPr>
         <p:spPr>
           <a:xfrm>
-            <a:off x="658368" y="2231136"/>
-            <a:ext cx="6903720" cy="2834640"/>
-          </a:xfrm>
-          <a:prstGeom prst="roundRect">
+            <a:off x="5102352" y="3456432"/>
+            <a:ext cx="9144" cy="1225296"/>
+          </a:xfrm>
+          <a:prstGeom prst="rect">
             <a:avLst/>
           </a:prstGeom>
           <a:solidFill>
-            <a:srgbClr val="FFFFFF"/>
+            <a:srgbClr val="D5DEE8"/>
           </a:solidFill>
-          <a:ln w="25400">
+          <a:ln w="15875">
             <a:solidFill>
-              <a:srgbClr val="748CA6"/>
+              <a:srgbClr val="D5DEE8"/>
             </a:solidFill>
           </a:ln>
         </p:spPr>
@@ -3595,44 +4108,66 @@
           </a:fontRef>
         </p:style>
         <p:txBody>
-          <a:bodyPr rtlCol="0" anchor="ctr" lIns="73152" rIns="73152" tIns="73152" bIns="73152"/>
+          <a:bodyPr rtlCol="0" anchor="ctr"/>
           <a:lstStyle/>
           <a:p>
             <a:pPr algn="ctr"/>
-            <a:r>
-              <a:rPr sz="1900" b="0">
-                <a:solidFill>
-                  <a:srgbClr val="172033"/>
+          </a:p>
+        </p:txBody>
+      </p:sp>
+      <p:sp>
+        <p:nvSpPr>
+          <p:cNvPr id="20" name="TextBox 19"/>
+          <p:cNvSpPr txBox="1"/>
+          <p:nvPr/>
+        </p:nvSpPr>
+        <p:spPr>
+          <a:xfrm>
+            <a:off x="5038344" y="4736592"/>
+            <a:ext cx="274320" cy="146304"/>
+          </a:xfrm>
+          <a:prstGeom prst="rect">
+            <a:avLst/>
+          </a:prstGeom>
+          <a:noFill/>
+        </p:spPr>
+        <p:txBody>
+          <a:bodyPr wrap="none" lIns="27432" rIns="27432" tIns="27432" bIns="27432">
+            <a:spAutoFit/>
+          </a:bodyPr>
+          <a:lstStyle/>
+          <a:p>
+            <a:r>
+              <a:rPr sz="1050" b="0">
+                <a:solidFill>
+                  <a:srgbClr val="586778"/>
                 </a:solidFill>
               </a:rPr>
-              <a:t>Incident trend
-P1 incidents: 3
-P2 incidents: 11
-P3 incidents: 28</a:t>
-            </a:r>
-          </a:p>
-        </p:txBody>
-      </p:sp>
-      <p:sp>
-        <p:nvSpPr>
-          <p:cNvPr id="8" name="Rectangle 7"/>
+              <a:t>20</a:t>
+            </a:r>
+          </a:p>
+        </p:txBody>
+      </p:sp>
+      <p:sp>
+        <p:nvSpPr>
+          <p:cNvPr id="21" name="Rectangle 20"/>
           <p:cNvSpPr/>
           <p:nvPr/>
         </p:nvSpPr>
         <p:spPr>
           <a:xfrm>
-            <a:off x="3127248" y="4169663"/>
-            <a:ext cx="658368" cy="137160"/>
+            <a:off x="6163055" y="3456432"/>
+            <a:ext cx="9144" cy="1225296"/>
           </a:xfrm>
           <a:prstGeom prst="rect">
             <a:avLst/>
           </a:prstGeom>
           <a:solidFill>
-            <a:srgbClr val="5B8DCB"/>
+            <a:srgbClr val="D5DEE8"/>
           </a:solidFill>
           <a:ln w="15875">
             <a:solidFill>
-              <a:srgbClr val="5B8DCB"/>
+              <a:srgbClr val="D5DEE8"/>
             </a:solidFill>
           </a:ln>
         </p:spPr>
@@ -3660,14 +4195,14 @@
       </p:sp>
       <p:sp>
         <p:nvSpPr>
-          <p:cNvPr id="9" name="TextBox 8"/>
+          <p:cNvPr id="22" name="TextBox 21"/>
           <p:cNvSpPr txBox="1"/>
           <p:nvPr/>
         </p:nvSpPr>
         <p:spPr>
           <a:xfrm>
-            <a:off x="2670048" y="4096511"/>
-            <a:ext cx="320040" cy="201168"/>
+            <a:off x="6099047" y="4736592"/>
+            <a:ext cx="274320" cy="146304"/>
           </a:xfrm>
           <a:prstGeom prst="rect">
             <a:avLst/>
@@ -3675,13 +4210,46 @@
           <a:noFill/>
         </p:spPr>
         <p:txBody>
-          <a:bodyPr wrap="none" lIns="73152" rIns="73152" tIns="73152" bIns="73152">
+          <a:bodyPr wrap="none" lIns="27432" rIns="27432" tIns="27432" bIns="27432">
             <a:spAutoFit/>
           </a:bodyPr>
           <a:lstStyle/>
           <a:p>
             <a:r>
-              <a:rPr sz="900" b="0">
+              <a:rPr sz="1050" b="0">
+                <a:solidFill>
+                  <a:srgbClr val="586778"/>
+                </a:solidFill>
+              </a:rPr>
+              <a:t>30</a:t>
+            </a:r>
+          </a:p>
+        </p:txBody>
+      </p:sp>
+      <p:sp>
+        <p:nvSpPr>
+          <p:cNvPr id="23" name="TextBox 22"/>
+          <p:cNvSpPr txBox="1"/>
+          <p:nvPr/>
+        </p:nvSpPr>
+        <p:spPr>
+          <a:xfrm>
+            <a:off x="2432304" y="3547872"/>
+            <a:ext cx="310896" cy="182880"/>
+          </a:xfrm>
+          <a:prstGeom prst="rect">
+            <a:avLst/>
+          </a:prstGeom>
+          <a:noFill/>
+        </p:spPr>
+        <p:txBody>
+          <a:bodyPr wrap="none" lIns="27432" rIns="27432" tIns="27432" bIns="27432">
+            <a:spAutoFit/>
+          </a:bodyPr>
+          <a:lstStyle/>
+          <a:p>
+            <a:r>
+              <a:rPr sz="1050" b="1">
                 <a:solidFill>
                   <a:srgbClr val="586778"/>
                 </a:solidFill>
@@ -3693,24 +4261,24 @@
       </p:sp>
       <p:sp>
         <p:nvSpPr>
-          <p:cNvPr id="10" name="Rectangle 9"/>
+          <p:cNvPr id="24" name="Rectangle 23"/>
           <p:cNvSpPr/>
           <p:nvPr/>
         </p:nvSpPr>
         <p:spPr>
           <a:xfrm>
-            <a:off x="3127248" y="4425696"/>
-            <a:ext cx="1572768" cy="137160"/>
+            <a:off x="2980944" y="3566160"/>
+            <a:ext cx="320040" cy="201168"/>
           </a:xfrm>
           <a:prstGeom prst="rect">
             <a:avLst/>
           </a:prstGeom>
           <a:solidFill>
-            <a:srgbClr val="447CB9"/>
+            <a:srgbClr val="77A6D2"/>
           </a:solidFill>
           <a:ln w="15875">
             <a:solidFill>
-              <a:srgbClr val="447CB9"/>
+              <a:srgbClr val="77A6D2"/>
             </a:solidFill>
           </a:ln>
         </p:spPr>
@@ -3738,14 +4306,14 @@
       </p:sp>
       <p:sp>
         <p:nvSpPr>
-          <p:cNvPr id="11" name="TextBox 10"/>
+          <p:cNvPr id="25" name="TextBox 24"/>
           <p:cNvSpPr txBox="1"/>
           <p:nvPr/>
         </p:nvSpPr>
         <p:spPr>
           <a:xfrm>
-            <a:off x="2670048" y="4352544"/>
-            <a:ext cx="320040" cy="201168"/>
+            <a:off x="3392424" y="3557016"/>
+            <a:ext cx="384048" cy="182880"/>
           </a:xfrm>
           <a:prstGeom prst="rect">
             <a:avLst/>
@@ -3753,13 +4321,46 @@
           <a:noFill/>
         </p:spPr>
         <p:txBody>
-          <a:bodyPr wrap="none" lIns="73152" rIns="73152" tIns="73152" bIns="73152">
+          <a:bodyPr wrap="none" lIns="27432" rIns="27432" tIns="27432" bIns="27432">
             <a:spAutoFit/>
           </a:bodyPr>
           <a:lstStyle/>
           <a:p>
             <a:r>
-              <a:rPr sz="900" b="0">
+              <a:rPr sz="1050" b="1">
+                <a:solidFill>
+                  <a:srgbClr val="172033"/>
+                </a:solidFill>
+              </a:rPr>
+              <a:t>3</a:t>
+            </a:r>
+          </a:p>
+        </p:txBody>
+      </p:sp>
+      <p:sp>
+        <p:nvSpPr>
+          <p:cNvPr id="26" name="TextBox 25"/>
+          <p:cNvSpPr txBox="1"/>
+          <p:nvPr/>
+        </p:nvSpPr>
+        <p:spPr>
+          <a:xfrm>
+            <a:off x="2432304" y="3968496"/>
+            <a:ext cx="310896" cy="182880"/>
+          </a:xfrm>
+          <a:prstGeom prst="rect">
+            <a:avLst/>
+          </a:prstGeom>
+          <a:noFill/>
+        </p:spPr>
+        <p:txBody>
+          <a:bodyPr wrap="none" lIns="27432" rIns="27432" tIns="27432" bIns="27432">
+            <a:spAutoFit/>
+          </a:bodyPr>
+          <a:lstStyle/>
+          <a:p>
+            <a:r>
+              <a:rPr sz="1050" b="1">
                 <a:solidFill>
                   <a:srgbClr val="586778"/>
                 </a:solidFill>
@@ -3771,14 +4372,125 @@
       </p:sp>
       <p:sp>
         <p:nvSpPr>
-          <p:cNvPr id="12" name="Rectangle 11"/>
+          <p:cNvPr id="27" name="Rectangle 26"/>
           <p:cNvSpPr/>
           <p:nvPr/>
         </p:nvSpPr>
         <p:spPr>
           <a:xfrm>
-            <a:off x="3127248" y="4681727"/>
-            <a:ext cx="3072384" cy="137160"/>
+            <a:off x="2980944" y="3986784"/>
+            <a:ext cx="1170432" cy="201168"/>
+          </a:xfrm>
+          <a:prstGeom prst="rect">
+            <a:avLst/>
+          </a:prstGeom>
+          <a:solidFill>
+            <a:srgbClr val="437DB7"/>
+          </a:solidFill>
+          <a:ln w="15875">
+            <a:solidFill>
+              <a:srgbClr val="437DB7"/>
+            </a:solidFill>
+          </a:ln>
+        </p:spPr>
+        <p:style>
+          <a:lnRef idx="1">
+            <a:schemeClr val="accent1"/>
+          </a:lnRef>
+          <a:fillRef idx="3">
+            <a:schemeClr val="accent1"/>
+          </a:fillRef>
+          <a:effectRef idx="2">
+            <a:schemeClr val="accent1"/>
+          </a:effectRef>
+          <a:fontRef idx="minor">
+            <a:schemeClr val="lt1"/>
+          </a:fontRef>
+        </p:style>
+        <p:txBody>
+          <a:bodyPr rtlCol="0" anchor="ctr"/>
+          <a:lstStyle/>
+          <a:p>
+            <a:pPr algn="ctr"/>
+          </a:p>
+        </p:txBody>
+      </p:sp>
+      <p:sp>
+        <p:nvSpPr>
+          <p:cNvPr id="28" name="TextBox 27"/>
+          <p:cNvSpPr txBox="1"/>
+          <p:nvPr/>
+        </p:nvSpPr>
+        <p:spPr>
+          <a:xfrm>
+            <a:off x="4242816" y="3977640"/>
+            <a:ext cx="384048" cy="182880"/>
+          </a:xfrm>
+          <a:prstGeom prst="rect">
+            <a:avLst/>
+          </a:prstGeom>
+          <a:noFill/>
+        </p:spPr>
+        <p:txBody>
+          <a:bodyPr wrap="none" lIns="27432" rIns="27432" tIns="27432" bIns="27432">
+            <a:spAutoFit/>
+          </a:bodyPr>
+          <a:lstStyle/>
+          <a:p>
+            <a:r>
+              <a:rPr sz="1050" b="1">
+                <a:solidFill>
+                  <a:srgbClr val="172033"/>
+                </a:solidFill>
+              </a:rPr>
+              <a:t>11</a:t>
+            </a:r>
+          </a:p>
+        </p:txBody>
+      </p:sp>
+      <p:sp>
+        <p:nvSpPr>
+          <p:cNvPr id="29" name="TextBox 28"/>
+          <p:cNvSpPr txBox="1"/>
+          <p:nvPr/>
+        </p:nvSpPr>
+        <p:spPr>
+          <a:xfrm>
+            <a:off x="2432304" y="4389120"/>
+            <a:ext cx="310896" cy="182880"/>
+          </a:xfrm>
+          <a:prstGeom prst="rect">
+            <a:avLst/>
+          </a:prstGeom>
+          <a:noFill/>
+        </p:spPr>
+        <p:txBody>
+          <a:bodyPr wrap="none" lIns="27432" rIns="27432" tIns="27432" bIns="27432">
+            <a:spAutoFit/>
+          </a:bodyPr>
+          <a:lstStyle/>
+          <a:p>
+            <a:r>
+              <a:rPr sz="1050" b="1">
+                <a:solidFill>
+                  <a:srgbClr val="586778"/>
+                </a:solidFill>
+              </a:rPr>
+              <a:t>P3</a:t>
+            </a:r>
+          </a:p>
+        </p:txBody>
+      </p:sp>
+      <p:sp>
+        <p:nvSpPr>
+          <p:cNvPr id="30" name="Rectangle 29"/>
+          <p:cNvSpPr/>
+          <p:nvPr/>
+        </p:nvSpPr>
+        <p:spPr>
+          <a:xfrm>
+            <a:off x="2980944" y="4407408"/>
+            <a:ext cx="2971800" cy="201168"/>
           </a:xfrm>
           <a:prstGeom prst="rect">
             <a:avLst/>
@@ -3816,14 +4528,14 @@
       </p:sp>
       <p:sp>
         <p:nvSpPr>
-          <p:cNvPr id="13" name="TextBox 12"/>
+          <p:cNvPr id="31" name="TextBox 30"/>
           <p:cNvSpPr txBox="1"/>
           <p:nvPr/>
         </p:nvSpPr>
         <p:spPr>
           <a:xfrm>
-            <a:off x="2670048" y="4608575"/>
-            <a:ext cx="320040" cy="201168"/>
+            <a:off x="6044183" y="4398264"/>
+            <a:ext cx="384048" cy="182880"/>
           </a:xfrm>
           <a:prstGeom prst="rect">
             <a:avLst/>
@@ -3831,32 +4543,32 @@
           <a:noFill/>
         </p:spPr>
         <p:txBody>
-          <a:bodyPr wrap="none" lIns="73152" rIns="73152" tIns="73152" bIns="73152">
+          <a:bodyPr wrap="none" lIns="27432" rIns="27432" tIns="27432" bIns="27432">
             <a:spAutoFit/>
           </a:bodyPr>
           <a:lstStyle/>
           <a:p>
             <a:r>
-              <a:rPr sz="900" b="0">
-                <a:solidFill>
-                  <a:srgbClr val="586778"/>
+              <a:rPr sz="1050" b="1">
+                <a:solidFill>
+                  <a:srgbClr val="172033"/>
                 </a:solidFill>
               </a:rPr>
-              <a:t>P3</a:t>
-            </a:r>
-          </a:p>
-        </p:txBody>
-      </p:sp>
-      <p:sp>
-        <p:nvSpPr>
-          <p:cNvPr id="14" name="queue_risk_caption"/>
+              <a:t>28</a:t>
+            </a:r>
+          </a:p>
+        </p:txBody>
+      </p:sp>
+      <p:sp>
+        <p:nvSpPr>
+          <p:cNvPr id="32" name="TextBox 31"/>
           <p:cNvSpPr txBox="1"/>
           <p:nvPr/>
         </p:nvSpPr>
         <p:spPr>
           <a:xfrm>
-            <a:off x="749808" y="5230368"/>
-            <a:ext cx="6675120" cy="384048"/>
+            <a:off x="932688" y="5010912"/>
+            <a:ext cx="6144768" cy="201168"/>
           </a:xfrm>
           <a:prstGeom prst="rect">
             <a:avLst/>
@@ -3864,6 +4576,39 @@
           <a:noFill/>
         </p:spPr>
         <p:txBody>
+          <a:bodyPr wrap="none" lIns="27432" rIns="27432" tIns="27432" bIns="27432">
+            <a:spAutoFit/>
+          </a:bodyPr>
+          <a:lstStyle/>
+          <a:p>
+            <a:r>
+              <a:rPr sz="1050" b="0">
+                <a:solidFill>
+                  <a:srgbClr val="586778"/>
+                </a:solidFill>
+              </a:rPr>
+              <a:t>Visual target: expanded from seed into the annotated left-middle analysis region.</a:t>
+            </a:r>
+          </a:p>
+        </p:txBody>
+      </p:sp>
+      <p:sp>
+        <p:nvSpPr>
+          <p:cNvPr id="33" name="queue_risk_caption"/>
+          <p:cNvSpPr txBox="1"/>
+          <p:nvPr/>
+        </p:nvSpPr>
+        <p:spPr>
+          <a:xfrm>
+            <a:off x="749808" y="5358384"/>
+            <a:ext cx="6675120" cy="384048"/>
+          </a:xfrm>
+          <a:prstGeom prst="rect">
+            <a:avLst/>
+          </a:prstGeom>
+          <a:noFill/>
+        </p:spPr>
+        <p:txBody>
           <a:bodyPr wrap="none" lIns="73152" rIns="73152" tIns="73152" bIns="73152">
             <a:spAutoFit/>
           </a:bodyPr>
@@ -3882,14 +4627,14 @@
       </p:sp>
       <p:sp>
         <p:nvSpPr>
-          <p:cNvPr id="15" name="action_owners"/>
+          <p:cNvPr id="34" name="action_owners"/>
           <p:cNvSpPr/>
           <p:nvPr/>
         </p:nvSpPr>
         <p:spPr>
           <a:xfrm>
-            <a:off x="8101583" y="2322576"/>
-            <a:ext cx="3273552" cy="1664208"/>
+            <a:off x="8101583" y="2304288"/>
+            <a:ext cx="3273552" cy="1792224"/>
           </a:xfrm>
           <a:prstGeom prst="roundRect">
             <a:avLst/>
@@ -3923,7 +4668,7 @@
           <a:p>
             <a:pPr algn="ctr"/>
             <a:r>
-              <a:rPr sz="1700" b="0">
+              <a:rPr sz="1500" b="0">
                 <a:solidFill>
                   <a:srgbClr val="172033"/>
                 </a:solidFill>
@@ -3931,21 +4676,75 @@
               <a:t>Action owners
 SRE: Priya
 Support: Marcus
-Comms: Lina</a:t>
-            </a:r>
-          </a:p>
-        </p:txBody>
-      </p:sp>
-      <p:sp>
-        <p:nvSpPr>
-          <p:cNvPr id="16" name="sev2_queue_risk"/>
+Comms: Lina
+Next checkpoint: Friday 16:00</a:t>
+            </a:r>
+          </a:p>
+        </p:txBody>
+      </p:sp>
+      <p:sp>
+        <p:nvSpPr>
+          <p:cNvPr id="35" name="Rounded Rectangle 34"/>
           <p:cNvSpPr/>
           <p:nvPr/>
         </p:nvSpPr>
         <p:spPr>
           <a:xfrm>
-            <a:off x="8101583" y="4645152"/>
-            <a:ext cx="3273552" cy="1298448"/>
+            <a:off x="8284464" y="3822191"/>
+            <a:ext cx="1993392" cy="310896"/>
+          </a:xfrm>
+          <a:prstGeom prst="roundRect">
+            <a:avLst/>
+          </a:prstGeom>
+          <a:solidFill>
+            <a:srgbClr val="FFFFFF"/>
+          </a:solidFill>
+          <a:ln w="15875">
+            <a:solidFill>
+              <a:srgbClr val="6FB5A0"/>
+            </a:solidFill>
+          </a:ln>
+        </p:spPr>
+        <p:style>
+          <a:lnRef idx="1">
+            <a:schemeClr val="accent1"/>
+          </a:lnRef>
+          <a:fillRef idx="3">
+            <a:schemeClr val="accent1"/>
+          </a:fillRef>
+          <a:effectRef idx="2">
+            <a:schemeClr val="accent1"/>
+          </a:effectRef>
+          <a:fontRef idx="minor">
+            <a:schemeClr val="lt1"/>
+          </a:fontRef>
+        </p:style>
+        <p:txBody>
+          <a:bodyPr rtlCol="0" anchor="ctr" lIns="36576" rIns="36576" tIns="36576" bIns="36576"/>
+          <a:lstStyle/>
+          <a:p>
+            <a:pPr algn="ctr"/>
+            <a:r>
+              <a:rPr sz="1150" b="1">
+                <a:solidFill>
+                  <a:srgbClr val="217D67"/>
+                </a:solidFill>
+              </a:rPr>
+              <a:t>EXEC HANDOFF READY</a:t>
+            </a:r>
+          </a:p>
+        </p:txBody>
+      </p:sp>
+      <p:sp>
+        <p:nvSpPr>
+          <p:cNvPr id="36" name="sev2_queue_risk"/>
+          <p:cNvSpPr/>
+          <p:nvPr/>
+        </p:nvSpPr>
+        <p:spPr>
+          <a:xfrm>
+            <a:off x="8101583" y="4590288"/>
+            <a:ext cx="3273552" cy="1371600"/>
           </a:xfrm>
           <a:prstGeom prst="roundRect">
             <a:avLst/>
@@ -3979,7 +4778,7 @@
           <a:p>
             <a:pPr algn="ctr"/>
             <a:r>
-              <a:rPr sz="1700" b="0">
+              <a:rPr sz="1500" b="0">
                 <a:solidFill>
                   <a:srgbClr val="172033"/>
                 </a:solidFill>
@@ -3987,6 +4786,92 @@
               <a:t>SEV-2 queue risk
 Escalation owner missing
 Annotate hotfix owner by Friday</a:t>
+            </a:r>
+          </a:p>
+        </p:txBody>
+      </p:sp>
+      <p:sp>
+        <p:nvSpPr>
+          <p:cNvPr id="37" name="Rounded Rectangle 36"/>
+          <p:cNvSpPr/>
+          <p:nvPr/>
+        </p:nvSpPr>
+        <p:spPr>
+          <a:xfrm>
+            <a:off x="658368" y="6144768"/>
+            <a:ext cx="2066543" cy="310896"/>
+          </a:xfrm>
+          <a:prstGeom prst="roundRect">
+            <a:avLst/>
+          </a:prstGeom>
+          <a:solidFill>
+            <a:srgbClr val="FFFFFF"/>
+          </a:solidFill>
+          <a:ln w="15875">
+            <a:solidFill>
+              <a:srgbClr val="E1E7EE"/>
+            </a:solidFill>
+          </a:ln>
+        </p:spPr>
+        <p:style>
+          <a:lnRef idx="1">
+            <a:schemeClr val="accent1"/>
+          </a:lnRef>
+          <a:fillRef idx="3">
+            <a:schemeClr val="accent1"/>
+          </a:fillRef>
+          <a:effectRef idx="2">
+            <a:schemeClr val="accent1"/>
+          </a:effectRef>
+          <a:fontRef idx="minor">
+            <a:schemeClr val="lt1"/>
+          </a:fontRef>
+        </p:style>
+        <p:txBody>
+          <a:bodyPr rtlCol="0" anchor="ctr" lIns="36576" rIns="36576" tIns="36576" bIns="36576"/>
+          <a:lstStyle/>
+          <a:p>
+            <a:pPr algn="ctr"/>
+            <a:r>
+              <a:rPr sz="1150" b="1">
+                <a:solidFill>
+                  <a:srgbClr val="586778"/>
+                </a:solidFill>
+              </a:rPr>
+              <a:t>Protected slides unchanged</a:t>
+            </a:r>
+          </a:p>
+        </p:txBody>
+      </p:sp>
+      <p:sp>
+        <p:nvSpPr>
+          <p:cNvPr id="38" name="TextBox 37"/>
+          <p:cNvSpPr txBox="1"/>
+          <p:nvPr/>
+        </p:nvSpPr>
+        <p:spPr>
+          <a:xfrm>
+            <a:off x="2871216" y="6199632"/>
+            <a:ext cx="4206240" cy="164592"/>
+          </a:xfrm>
+          <a:prstGeom prst="rect">
+            <a:avLst/>
+          </a:prstGeom>
+          <a:noFill/>
+        </p:spPr>
+        <p:txBody>
+          <a:bodyPr wrap="none" lIns="27432" rIns="27432" tIns="27432" bIns="27432">
+            <a:spAutoFit/>
+          </a:bodyPr>
+          <a:lstStyle/>
+          <a:p>
+            <a:r>
+              <a:rPr sz="1050" b="0">
+                <a:solidFill>
+                  <a:srgbClr val="586778"/>
+                </a:solidFill>
+              </a:rPr>
+              <a:t>Generated gold reference for CUIF annotated-screenshot edit task</a:t>
             </a:r>
           </a:p>
         </p:txBody>

</xml_diff>